<commit_message>
docs(İT-15 son cila): test sayısı tutarlılık sweep (210→649) README/sunum/demo/ticarileşme/uyum-matrisi + sunum PDF/PPTX yeniden üretildi; final QA yeşil
</commit_message>
<xml_diff>
--- a/docs/sunum/final.pptx
+++ b/docs/sunum/final.pptx
@@ -575,12 +575,17 @@
           <a:lstStyle/>
           <a:p>
             <a:r>
-              <a:t>Kapanış cümlesi: "Çalışan bir sistem, dürüst ölçümler ve temiz bir lisans getirdik —</a:t>
-            </a:r>
-          </a:p>
-          <a:p>
-            <a:r>
-              <a:t>ve internet kesilse bile demomuz durmuyor. Teşekkürler."</a:t>
+              <a:t>Kapanış cümlesi: "Çalışan bir sistem, dürüst ölçümler — gpt-4o ile dairesel-olmayan</a:t>
+            </a:r>
+          </a:p>
+          <a:p>
+            <a:r>
+              <a:t>held-out'ta ~%90 doğruluk — ve temiz bir MIT lisans getirdik; internet kesilse bile</a:t>
+            </a:r>
+          </a:p>
+          <a:p>
+            <a:r>
+              <a:t>demomuz durmuyor. Teşekkürler."</a:t>
             </a:r>
           </a:p>
         </p:txBody>
@@ -660,52 +665,62 @@
           </a:p>
           <a:p>
             <a:r>
-              <a:t>Cevap: "Üç katmanlı ve dürüst bir cevap vereyim:</a:t>
-            </a:r>
-          </a:p>
-          <a:p>
-            <a:r>
-              <a:t>1. Mock taban: Yayınlanan karne LLM_MODE=mock — yani LLM yerine kural-tabanlı keyword/regex</a:t>
-            </a:r>
-          </a:p>
-          <a:p>
-            <a:r>
-              <a:t>fallback. Bu modda sınıflandırma macro-F1 0.919, yönlendirme Top-1 0.931, eksik-bilgi</a:t>
-            </a:r>
-          </a:p>
-          <a:p>
-            <a:r>
-              <a:t>recall 0.995. Ama bunlar in-domain — yani sentetik gold ile aynı dağıtımdan.</a:t>
-            </a:r>
-          </a:p>
-          <a:p>
-            <a:r>
-              <a:t>2. Held-out (dürüst): Üreticinin görmediği ayrı şablon/sözlükle ölçtüğümüzde mock macro-F1</a:t>
-            </a:r>
-          </a:p>
-          <a:p>
-            <a:r>
-              <a:t>0.22'ye düşüyor. Bunu gizlemiyoruz — kural tabanının genellemediğini kanıtlıyor.</a:t>
-            </a:r>
-          </a:p>
-          <a:p>
-            <a:r>
-              <a:t>3. Gerçek-LLM (tavan): Asıl değer few-shot LLM modunda. Prompt hazır; OPENAI_API_KEY ya da</a:t>
-            </a:r>
-          </a:p>
-          <a:p>
-            <a:r>
-              <a:t>lokal Qwen ile aynı pipeline'ı koşar, kural-tablosuna bağlı olmadığı için held-out'ta da çalışır.</a:t>
-            </a:r>
-          </a:p>
-          <a:p>
-            <a:r>
-              <a:t>Yani önemli olan: eval'imiz mock taksonomi değil gerçek LangGraph pipeline'ı ölçüyor, ve mock</a:t>
-            </a:r>
-          </a:p>
-          <a:p>
-            <a:r>
-              <a:t>tavanı sahte sabitlemiyoruz. Tüm sayılar Wilson %95 güven aralıklı." (Kanıt: docs/benchmark/scorecard.md, docs/method.md §2.1.)</a:t>
+              <a:t>Cevap: "Dürüst ve ölçülmüş bir cevap vereyim — ilerlemeyi aynı zor sette gösterebilirim:</a:t>
+            </a:r>
+          </a:p>
+          <a:p>
+            <a:r>
+              <a:t>1. Mock taban (anahtarsız): LLM_MODE=mock — LLM yerine kural-tabanlı keyword/regex fallback.</a:t>
+            </a:r>
+          </a:p>
+          <a:p>
+            <a:r>
+              <a:t>CI/offline tabanı; tavan değil. Dairesel-olmayan held-out'ta sıkı macro-F1 sadece 0.22 —</a:t>
+            </a:r>
+          </a:p>
+          <a:p>
+            <a:r>
+              <a:t>bunu gizlemiyoruz, kural tabanının genellemediğini kanıtlıyor.</a:t>
+            </a:r>
+          </a:p>
+          <a:p>
+            <a:r>
+              <a:t>2. gpt-4o-mini: Aynı held-out sette 0.61.</a:t>
+            </a:r>
+          </a:p>
+          <a:p>
+            <a:r>
+              <a:t>3. gpt-4o (üretim tavanı): Aynı sette sıkı macro-F1 0.908, operasyonel accuracy 0.935,</a:t>
+            </a:r>
+          </a:p>
+          <a:p>
+            <a:r>
+              <a:t>yönlendirme Top-1 0.926 — 108 evrakta 98 doğru. Hepsi Wilson %95 güven aralıklı.</a:t>
+            </a:r>
+          </a:p>
+          <a:p>
+            <a:r>
+              <a:t>Kritik nokta — bu held-out dairesel DEĞİL: evraklar örtük/dolaylı ifadeyle, gen_synthetic'ten</a:t>
+            </a:r>
+          </a:p>
+          <a:p>
+            <a:r>
+              <a:t>farklı şablon ve sözlükle yazıldı; keyword sızıntısı yok. Yani ilerleme **mock 0.22 → mini 0.61 →</a:t>
+            </a:r>
+          </a:p>
+          <a:p>
+            <a:r>
+              <a:t>gpt-4o 0.91 gerçek bir genelleme sıçraması. Eval'imiz mock taksonomi değil gerçek LangGraph</a:t>
+            </a:r>
+          </a:p>
+          <a:p>
+            <a:r>
+              <a:t>pipeline'ı** ölçüyor. Üretim önerimiz açık: LLM_MODE=openai + gpt-4o." (Kanıt:</a:t>
+            </a:r>
+          </a:p>
+          <a:p>
+            <a:r>
+              <a:t>docs/benchmark/llm-heldout.md, docs/benchmark/scorecard.md, docs/method.md §2.1.)</a:t>
             </a:r>
           </a:p>
           <a:p>
@@ -825,12 +840,22 @@
           </a:p>
           <a:p>
             <a:r>
-              <a:t>link+sürüm+lisansla dokümante. Sistem hem bulutta hem kurum-içi offline çalışabildiği için kamu</a:t>
-            </a:r>
-          </a:p>
-          <a:p>
-            <a:r>
-              <a:t>gizliliği için kurum-içi konuşlandırma mümkün — ticarileşme avantajı." (Kanıt: docs/07-model-lisanslari.md, LICENSE.)</a:t>
+              <a:t>link+sürüm+lisansla dokümante. Hedef müşteri kamu kurumları ve EBYS/DYS operatörleri: değer önermesi</a:t>
+            </a:r>
+          </a:p>
+          <a:p>
+            <a:r>
+              <a:t>evrak işleme süresinde ve havale hatasında düşüş. EBYS/e-Yazışma API'siyle entegre olur; çok-kurum</a:t>
+            </a:r>
+          </a:p>
+          <a:p>
+            <a:r>
+              <a:t>SaaS veya kurum-içi on-prem (offline, KVKK) konuşlandırılır — iş modeli lisans/SaaS/kamu ihale.</a:t>
+            </a:r>
+          </a:p>
+          <a:p>
+            <a:r>
+              <a:t>Tam anlatım docs/ticarileşme.md'de." (Kanıt: docs/ticarileşme.md, docs/07-model-lisanslari.md, LICENSE.)</a:t>
             </a:r>
           </a:p>
           <a:p>
@@ -860,22 +885,27 @@
           </a:p>
           <a:p>
             <a:r>
-              <a:t>Cevap (dürüst): "Üç açık var, hepsini matriste işaretledik: (1) Gerçek-LLM skor ölçümü —</a:t>
-            </a:r>
-          </a:p>
-          <a:p>
-            <a:r>
-              <a:t>şu an mock taban, anahtar verilince ölçeceğiz; (2) Blind insan-etiketli gold — otomatik etiketler</a:t>
-            </a:r>
-          </a:p>
-          <a:p>
-            <a:r>
-              <a:t>bağımsız onaydan geçmeli; (3) Held-out genelleme — kural tabanı genellemiyor, asıl çözüm LLM modu.</a:t>
-            </a:r>
-          </a:p>
-          <a:p>
-            <a:r>
-              <a:t>İdari tarafta 4. takım üyesi tamamlanıyor. Bunları gizlemiyoruz çünkü dürüst ölçüm jüri güveni demek." (Kanıt: docs/sartname-uyum-matrisi.md §G.)</a:t>
+              <a:t>Cevap (dürüst): "Üç açık var, hepsini matriste işaretledik: (1) Tek held-out set riski —</a:t>
+            </a:r>
+          </a:p>
+          <a:p>
+            <a:r>
+              <a:t>gerçek-LLM skorunu (gpt-4o 0.91) ölçtük ama tek sette; 2. bağımsız set ile çapraz-doğrulamak istiyoruz;</a:t>
+            </a:r>
+          </a:p>
+          <a:p>
+            <a:r>
+              <a:t>(2) Blind insan-etiketli gold — otomatik etiketler bağımsız onaydan geçmeli; (3) Canlı OCR'ın uçtan-uca</a:t>
+            </a:r>
+          </a:p>
+          <a:p>
+            <a:r>
+              <a:t>gerçek-evrak akışında genişletilmesi. İdari tarafta 4. takım üyesi tamamlanıyor. Bunları gizlemiyoruz</a:t>
+            </a:r>
+          </a:p>
+          <a:p>
+            <a:r>
+              <a:t>çünkü dürüst ölçüm jüri güveni demek." (Kanıt: docs/benchmark/llm-heldout.md, docs/sartname-uyum-matrisi.md §G.)</a:t>
             </a:r>
           </a:p>
           <a:p>
@@ -4047,13 +4077,13 @@
           <a:p>
             <a:pPr lvl="1"/>
             <a:r>
-              <a:t>Ana mesaj: mock taban / held-out / gerçek-LLM ayrımı</a:t>
+              <a:t>Ana mesaj: mock 0.22 → mini 0.61 → gpt-4o 0.91 held-out (dairesel-olmayan)</a:t>
             </a:r>
           </a:p>
           <a:p>
             <a:pPr lvl="1"/>
             <a:r>
-              <a:t>Görsel / Aksiyon: Skor tablosu + held-out notu</a:t>
+              <a:t>Görsel / Aksiyon: Skor tablosu + llm-heldout.md</a:t>
             </a:r>
           </a:p>
           <a:p>
@@ -4071,13 +4101,13 @@
           <a:p>
             <a:pPr lvl="1"/>
             <a:r>
-              <a:t>Ana mesaj: PII maskeleme, ENV-gated SOTA, MIT yığın, offline</a:t>
+              <a:t>Ana mesaj: PII maskeleme, ENV-gated SOTA, MIT yığın, EBYS/SaaS/on-prem</a:t>
             </a:r>
           </a:p>
           <a:p>
             <a:pPr lvl="1"/>
             <a:r>
-              <a:t>Görsel / Aksiyon: Yenilikçilik slaytı</a:t>
+              <a:t>Görsel / Aksiyon: Ticarileşme slaytı (ticarileşme.md)</a:t>
             </a:r>
           </a:p>
           <a:p>
@@ -4270,19 +4300,19 @@
           <a:p>
             <a:pPr/>
             <a:r>
-              <a:t>8. Dürüst skor — mock taban / held-out 0.22 / gerçek-LLM tavan (few-shot hazır).</a:t>
+              <a:t>8. Dürüst skor — held-out ilerleme: mock 0.22 → mini 0.61 → gpt-4o 0.91 (op. 0.93 / Top-1 0.93, 98/108).</a:t>
             </a:r>
           </a:p>
           <a:p>
             <a:pPr/>
             <a:r>
-              <a:t>9. Yenilikçilik + ticarileşme — PII maskeleme, ENV-gated CRAG/Self-RAG, MIT, offline kurum-içi.</a:t>
+              <a:t>9. Yenilikçilik + ticarileşme — PII maskeleme, ENV-gated CRAG/Self-RAG, MIT; EBYS entegrasyonu, SaaS/on-prem (ticarileşme.md).</a:t>
             </a:r>
           </a:p>
           <a:p>
             <a:pPr/>
             <a:r>
-              <a:t>10. Kapanış — Görev 1 (6/6) + Görev 2 (5/5), 210 test, CI; yol haritası; kapanış cümlesi.</a:t>
+              <a:t>10. Kapanış — Görev 1 (6/6) + Görev 2 (5/5), 649 test, CI; yol haritası; kapanış cümlesi.</a:t>
             </a:r>
           </a:p>
         </p:txBody>

</xml_diff>

<commit_message>
docs(İT-18): sunum PDF/PPTX yeni animasyonlu-UI görselleriyle yeniden üretildi + README'ye gömülü demo.gif (canlı demo öne çıkarıldı); final QA yeşil (pytest 649/boot/build)
</commit_message>
<xml_diff>
--- a/docs/sunum/final.pptx
+++ b/docs/sunum/final.pptx
@@ -4334,7 +4334,7 @@
         <p:spPr>
           <a:xfrm>
             <a:off x="5029200" y="2057400"/>
-            <a:ext cx="3840480" cy="1059972"/>
+            <a:ext cx="3840480" cy="5258968"/>
           </a:xfrm>
           <a:prstGeom prst="rect">
             <a:avLst/>
@@ -4473,7 +4473,7 @@
         <p:spPr>
           <a:xfrm>
             <a:off x="5029200" y="2057400"/>
-            <a:ext cx="3840480" cy="4404857"/>
+            <a:ext cx="3840480" cy="5228153"/>
           </a:xfrm>
           <a:prstGeom prst="rect">
             <a:avLst/>

</xml_diff>